<commit_message>
feat: add OptiCart presentation deck and interactive live demo script
</commit_message>
<xml_diff>
--- a/presentation/OptiCart_Main.pptx
+++ b/presentation/OptiCart_Main.pptx
@@ -323,7 +323,7 @@
           <a:p>
             <a:fld id="{5BCAD085-E8A6-8845-BD4E-CB4CCA059FC4}" type="datetimeFigureOut">
               <a:rPr lang="en-US" smtClean="0"/>
-              <a:t>7/11/2026</a:t>
+              <a:t>7/13/2026</a:t>
             </a:fld>
             <a:endParaRPr lang="en-US"/>
           </a:p>
@@ -491,7 +491,7 @@
           <a:p>
             <a:fld id="{5BCAD085-E8A6-8845-BD4E-CB4CCA059FC4}" type="datetimeFigureOut">
               <a:rPr lang="en-US" smtClean="0"/>
-              <a:t>7/11/2026</a:t>
+              <a:t>7/13/2026</a:t>
             </a:fld>
             <a:endParaRPr lang="en-US"/>
           </a:p>
@@ -669,7 +669,7 @@
           <a:p>
             <a:fld id="{5BCAD085-E8A6-8845-BD4E-CB4CCA059FC4}" type="datetimeFigureOut">
               <a:rPr lang="en-US" smtClean="0"/>
-              <a:t>7/11/2026</a:t>
+              <a:t>7/13/2026</a:t>
             </a:fld>
             <a:endParaRPr lang="en-US"/>
           </a:p>
@@ -837,7 +837,7 @@
           <a:p>
             <a:fld id="{5BCAD085-E8A6-8845-BD4E-CB4CCA059FC4}" type="datetimeFigureOut">
               <a:rPr lang="en-US" smtClean="0"/>
-              <a:t>7/11/2026</a:t>
+              <a:t>7/13/2026</a:t>
             </a:fld>
             <a:endParaRPr lang="en-US"/>
           </a:p>
@@ -1082,7 +1082,7 @@
           <a:p>
             <a:fld id="{5BCAD085-E8A6-8845-BD4E-CB4CCA059FC4}" type="datetimeFigureOut">
               <a:rPr lang="en-US" smtClean="0"/>
-              <a:t>7/11/2026</a:t>
+              <a:t>7/13/2026</a:t>
             </a:fld>
             <a:endParaRPr lang="en-US"/>
           </a:p>
@@ -1367,7 +1367,7 @@
           <a:p>
             <a:fld id="{5BCAD085-E8A6-8845-BD4E-CB4CCA059FC4}" type="datetimeFigureOut">
               <a:rPr lang="en-US" smtClean="0"/>
-              <a:t>7/11/2026</a:t>
+              <a:t>7/13/2026</a:t>
             </a:fld>
             <a:endParaRPr lang="en-US"/>
           </a:p>
@@ -1786,7 +1786,7 @@
           <a:p>
             <a:fld id="{5BCAD085-E8A6-8845-BD4E-CB4CCA059FC4}" type="datetimeFigureOut">
               <a:rPr lang="en-US" smtClean="0"/>
-              <a:t>7/11/2026</a:t>
+              <a:t>7/13/2026</a:t>
             </a:fld>
             <a:endParaRPr lang="en-US"/>
           </a:p>
@@ -1903,7 +1903,7 @@
           <a:p>
             <a:fld id="{5BCAD085-E8A6-8845-BD4E-CB4CCA059FC4}" type="datetimeFigureOut">
               <a:rPr lang="en-US" smtClean="0"/>
-              <a:t>7/11/2026</a:t>
+              <a:t>7/13/2026</a:t>
             </a:fld>
             <a:endParaRPr lang="en-US"/>
           </a:p>
@@ -1998,7 +1998,7 @@
           <a:p>
             <a:fld id="{5BCAD085-E8A6-8845-BD4E-CB4CCA059FC4}" type="datetimeFigureOut">
               <a:rPr lang="en-US" smtClean="0"/>
-              <a:t>7/11/2026</a:t>
+              <a:t>7/13/2026</a:t>
             </a:fld>
             <a:endParaRPr lang="en-US"/>
           </a:p>
@@ -2273,7 +2273,7 @@
           <a:p>
             <a:fld id="{5BCAD085-E8A6-8845-BD4E-CB4CCA059FC4}" type="datetimeFigureOut">
               <a:rPr lang="en-US" smtClean="0"/>
-              <a:t>7/11/2026</a:t>
+              <a:t>7/13/2026</a:t>
             </a:fld>
             <a:endParaRPr lang="en-US"/>
           </a:p>
@@ -2525,7 +2525,7 @@
           <a:p>
             <a:fld id="{5BCAD085-E8A6-8845-BD4E-CB4CCA059FC4}" type="datetimeFigureOut">
               <a:rPr lang="en-US" smtClean="0"/>
-              <a:t>7/11/2026</a:t>
+              <a:t>7/13/2026</a:t>
             </a:fld>
             <a:endParaRPr lang="en-US"/>
           </a:p>
@@ -2736,7 +2736,7 @@
           <a:p>
             <a:fld id="{5BCAD085-E8A6-8845-BD4E-CB4CCA059FC4}" type="datetimeFigureOut">
               <a:rPr lang="en-US" smtClean="0"/>
-              <a:t>7/11/2026</a:t>
+              <a:t>7/13/2026</a:t>
             </a:fld>
             <a:endParaRPr lang="en-US"/>
           </a:p>
@@ -6435,7 +6435,7 @@
               </a:spcAft>
             </a:pPr>
             <a:r>
-              <a:rPr sz="1400" b="1">
+              <a:rPr sz="1400" b="1" dirty="0">
                 <a:solidFill>
                   <a:srgbClr val="F8FAFC"/>
                 </a:solidFill>
@@ -6454,7 +6454,7 @@
               </a:spcAft>
             </a:pPr>
             <a:r>
-              <a:rPr sz="1250" b="0">
+              <a:rPr sz="1250" b="0" dirty="0">
                 <a:solidFill>
                   <a:srgbClr val="94A3B8"/>
                 </a:solidFill>
@@ -14949,7 +14949,7 @@
         <p:spPr>
           <a:xfrm>
             <a:off x="640080" y="1554480"/>
-            <a:ext cx="7680960" cy="4572000"/>
+            <a:ext cx="7680960" cy="2404504"/>
           </a:xfrm>
           <a:prstGeom prst="rect">
             <a:avLst/>
@@ -14971,13 +14971,31 @@
               </a:spcAft>
             </a:pPr>
             <a:r>
-              <a:rPr sz="1700" b="0">
+              <a:rPr sz="1700" b="0" dirty="0">
                 <a:solidFill>
                   <a:srgbClr val="E2E8F0"/>
                 </a:solidFill>
                 <a:latin typeface="Segoe UI"/>
               </a:rPr>
-              <a:t>•  Planned as 11 epics → 40 sub-tasks → 311 story points, split evenly by strength (Jira board).</a:t>
+              <a:t>•  Planned as 11 </a:t>
+            </a:r>
+            <a:r>
+              <a:rPr lang="en-US" sz="1700" b="0" dirty="0">
+                <a:solidFill>
+                  <a:srgbClr val="E2E8F0"/>
+                </a:solidFill>
+                <a:latin typeface="Segoe UI"/>
+              </a:rPr>
+              <a:t>stories</a:t>
+            </a:r>
+            <a:r>
+              <a:rPr sz="1700" b="0" dirty="0">
+                <a:solidFill>
+                  <a:srgbClr val="E2E8F0"/>
+                </a:solidFill>
+                <a:latin typeface="Segoe UI"/>
+              </a:rPr>
+              <a:t> → 40 sub-tasks → 311 story points, split evenly by strength (Jira board).</a:t>
             </a:r>
           </a:p>
           <a:p>
@@ -14990,7 +15008,7 @@
               </a:spcAft>
             </a:pPr>
             <a:r>
-              <a:rPr sz="1700" b="0">
+              <a:rPr sz="1700" b="0" dirty="0">
                 <a:solidFill>
                   <a:srgbClr val="E2E8F0"/>
                 </a:solidFill>
@@ -15009,7 +15027,7 @@
               </a:spcAft>
             </a:pPr>
             <a:r>
-              <a:rPr sz="1500" b="0">
+              <a:rPr sz="1500" b="0" dirty="0">
                 <a:solidFill>
                   <a:srgbClr val="94A3B8"/>
                 </a:solidFill>
@@ -15028,7 +15046,7 @@
               </a:spcAft>
             </a:pPr>
             <a:r>
-              <a:rPr sz="1500" b="0">
+              <a:rPr sz="1500" b="0" dirty="0">
                 <a:solidFill>
                   <a:srgbClr val="94A3B8"/>
                 </a:solidFill>
@@ -15047,7 +15065,7 @@
               </a:spcAft>
             </a:pPr>
             <a:r>
-              <a:rPr sz="1700" b="0">
+              <a:rPr sz="1700" b="0" dirty="0">
                 <a:solidFill>
                   <a:srgbClr val="E2E8F0"/>
                 </a:solidFill>

</xml_diff>